<commit_message>
Week 4 Wednesday: causal tests belong to Monday's faculty session, and the fallback cites OpenStax alone
The draft gave causal testing to Week 5, which teaches regression; the faculty
sessions file puts experiment design in W4-1. The fallback deck dropped a
Newsweek citation whose page carries no Pop-Tarts figure, and no slide names a
number of groups the programme facts do not set. Decks rebuilt, notebook 03
re-executed.

Co-Authored-By: Claude Opus 5.5 <noreply@anthropic.com>
Claude-Session: https://claude.ai/code/session_01NN5zp6kMYG3SQZMpC3fcxc
</commit_message>
<xml_diff>
--- a/content/W04/D3/slides/C2_W04_D03_fallback_STUDENT.pptx
+++ b/content/W04/D3/slides/C2_W04_D03_fallback_STUDENT.pptx
@@ -1199,7 +1199,7 @@
           <a:lstStyle/>
           <a:p>
             <a:r>
-              <a:t>LIVE, 1 minute. The faculty session (tentative) runs when IITGN next confirms a slot. Tomorrow's</a:t>
+              <a:t>LIVE, 1 minute. Say only that the faculty session (tentative) did not run today. Tomorrow's</a:t>
             </a:r>
           </a:p>
           <a:p>
@@ -1809,7 +1809,7 @@
           <a:lstStyle/>
           <a:p>
             <a:r>
-              <a:t>LIVE, 25 minutes of group work. Groups 5 and 6 find the stock-out in their own slice: curd's pairs</a:t>
+              <a:t>LIVE, 25 minutes of group work. The fifth and sixth groups find the stock-out in their own slice: curd's pairs</a:t>
             </a:r>
           </a:p>
           <a:p>
@@ -7476,7 +7476,7 @@
                 </a:solidFill>
                 <a:latin typeface="Calibri"/>
               </a:rPr>
-              <a:t>Week 4 Day 3: what goes with what, beyond chance</a:t>
+              <a:t>Week 4, Day 3. Instamart Pune: the watch list, one zone, and a storm</a:t>
             </a:r>
           </a:p>
         </p:txBody>
@@ -7815,7 +7815,7 @@
                 </a:solidFill>
                 <a:latin typeface="Calibri"/>
               </a:rPr>
-              <a:t>Walmart's analysts had seen strawberry Pop-Tart sales rise about seven times before Hurricane Charley, so when Hurricane Frances was forecast the chain shipped extra Pop-Tarts to the stores in its path (OpenStax and Newsweek, checked 12 October 2026). The decision moved stock ahead of the storm; a wrong forecast would have left it on the wrong shelves.</a:t>
+              <a:t>Walmart's analysts had seen strawberry Pop-Tart sales rise about seven times before Hurricane Charley, so when Hurricane Frances was forecast the chain shipped extra Pop-Tarts to the stores in its path (OpenStax, checked 12 October 2026). The decision moved stock ahead of the storm; a wrong forecast would have left it on the wrong shelves.</a:t>
             </a:r>
           </a:p>
         </p:txBody>
@@ -10145,7 +10145,7 @@
                 </a:solidFill>
                 <a:latin typeface="Calibri"/>
               </a:rPr>
-              <a:t>Week 4 Day 3: what goes with what, beyond chance</a:t>
+              <a:t>Week 4, Day 3. Instamart Pune: the watch list, one zone, and a storm</a:t>
             </a:r>
           </a:p>
         </p:txBody>
@@ -16020,7 +16020,7 @@
                 </a:solidFill>
                 <a:latin typeface="Calibri"/>
               </a:rPr>
-              <a:t>Week 4 Day 3: what goes with what, beyond chance</a:t>
+              <a:t>Week 4, Day 3. Instamart Pune: the watch list, one zone, and a storm</a:t>
             </a:r>
           </a:p>
         </p:txBody>
@@ -19392,7 +19392,7 @@
                 </a:solidFill>
                 <a:latin typeface="Calibri"/>
               </a:rPr>
-              <a:t>Week 4 Day 3: what goes with what, beyond chance</a:t>
+              <a:t>Week 4, Day 3. Instamart Pune: the watch list, one zone, and a storm</a:t>
             </a:r>
           </a:p>
         </p:txBody>
@@ -20535,7 +20535,7 @@
                 </a:solidFill>
                 <a:latin typeface="Georgia"/>
               </a:rPr>
-              <a:t>Nine groups, nine slices, one report each</a:t>
+              <a:t>Each group takes one slice and reports on it</a:t>
             </a:r>
           </a:p>
         </p:txBody>
@@ -20585,7 +20585,7 @@
         </p:nvGraphicFramePr>
         <p:xfrm>
           <a:off x="530352" y="1956816"/>
-          <a:ext cx="11130990" cy="2090928"/>
+          <a:ext cx="11130989" cy="2816352"/>
         </p:xfrm>
         <a:graphic>
           <a:graphicData uri="http://schemas.openxmlformats.org/drawingml/2006/table">
@@ -20594,9 +20594,9 @@
                 <a:tableStyleId>{2D5ABB26-0587-4C30-8999-92F81FD0307C}</a:tableStyleId>
               </a:tblPr>
               <a:tblGrid>
-                <a:gridCol w="914400"/>
-                <a:gridCol w="4267247"/>
-                <a:gridCol w="5949343"/>
+                <a:gridCol w="1750610"/>
+                <a:gridCol w="3917980"/>
+                <a:gridCol w="5462399"/>
               </a:tblGrid>
               <a:tr h="369824">
                 <a:tc>
@@ -20611,7 +20611,7 @@
                           </a:solidFill>
                           <a:latin typeface="Calibri"/>
                         </a:rPr>
-                        <a:t>Groups</a:t>
+                        <a:t>Group</a:t>
                       </a:r>
                     </a:p>
                   </a:txBody>
@@ -20679,7 +20679,7 @@
                           </a:solidFill>
                           <a:latin typeface="Calibri"/>
                         </a:rPr>
-                        <a:t>1 and 2</a:t>
+                        <a:t>First and second</a:t>
                       </a:r>
                     </a:p>
                   </a:txBody>
@@ -20734,7 +20734,7 @@
                   </a:tcPr>
                 </a:tc>
               </a:tr>
-              <a:tr h="369824">
+              <a:tr h="611632">
                 <a:tc>
                   <a:txBody>
                     <a:bodyPr/>
@@ -20747,7 +20747,7 @@
                           </a:solidFill>
                           <a:latin typeface="Calibri"/>
                         </a:rPr>
-                        <a:t>3 and 4</a:t>
+                        <a:t>Third and fourth</a:t>
                       </a:r>
                     </a:p>
                   </a:txBody>
@@ -20802,7 +20802,7 @@
                   </a:tcPr>
                 </a:tc>
               </a:tr>
-              <a:tr h="369824">
+              <a:tr h="611632">
                 <a:tc>
                   <a:txBody>
                     <a:bodyPr/>
@@ -20815,7 +20815,7 @@
                           </a:solidFill>
                           <a:latin typeface="Calibri"/>
                         </a:rPr>
-                        <a:t>5 and 6</a:t>
+                        <a:t>Fifth and sixth</a:t>
                       </a:r>
                     </a:p>
                   </a:txBody>
@@ -20870,7 +20870,7 @@
                   </a:tcPr>
                 </a:tc>
               </a:tr>
-              <a:tr h="369824">
+              <a:tr h="611632">
                 <a:tc>
                   <a:txBody>
                     <a:bodyPr/>
@@ -20883,7 +20883,7 @@
                           </a:solidFill>
                           <a:latin typeface="Calibri"/>
                         </a:rPr>
-                        <a:t>7 to 9</a:t>
+                        <a:t>Any further group</a:t>
                       </a:r>
                     </a:p>
                   </a:txBody>

</xml_diff>

<commit_message>
Week 4 Wednesday fix pass: the decks define every business word where it first appears
The ticket names impressions, slots, the anchor item, adds and who asks; the
second route and the rearranged lift are shown before they are used; rounding
slips are gone (10,064 against 9,656, 0.354, Rs 41.77); the six doubts are six;
the watch list rests on the anchor-based reason; the interview slides carry the
rewritten answers, and the fallback compares randomised shoppers and says no
rate fell while the mix moved.

Co-Authored-By: Claude Opus 5.5 <noreply@anthropic.com>
Claude-Session: https://claude.ai/code/session_01NN5zp6kMYG3SQZMpC3fcxc
</commit_message>
<xml_diff>
--- a/content/W04/D3/slides/C2_W04_D03_fallback_STUDENT.pptx
+++ b/content/W04/D3/slides/C2_W04_D03_fallback_STUDENT.pptx
@@ -1053,7 +1053,7 @@
           <a:lstStyle/>
           <a:p>
             <a:r>
-              <a:t>LIVE, 7 minutes. The sentence to carry: "a redesign is worth testing; the ranking is what fell".</a:t>
+              <a:t>LIVE, 7 minutes. The sentence to carry: "no rate fell; the mix moved, and a layout gets its own test".</a:t>
             </a:r>
           </a:p>
           <a:p>
@@ -7289,7 +7289,7 @@
         <p:spPr>
           <a:xfrm>
             <a:off x="530352" y="2843784"/>
-            <a:ext cx="2645587" cy="1249680"/>
+            <a:ext cx="2645587" cy="1595120"/>
           </a:xfrm>
           <a:prstGeom prst="roundRect">
             <a:avLst>
@@ -7492,7 +7492,7 @@
         <p:spPr>
           <a:xfrm>
             <a:off x="3358819" y="2843784"/>
-            <a:ext cx="2645587" cy="1249680"/>
+            <a:ext cx="2645587" cy="1595120"/>
           </a:xfrm>
           <a:prstGeom prst="roundRect">
             <a:avLst>
@@ -7695,7 +7695,7 @@
         <p:spPr>
           <a:xfrm>
             <a:off x="6187287" y="2843784"/>
-            <a:ext cx="2645587" cy="1249680"/>
+            <a:ext cx="2645587" cy="1595120"/>
           </a:xfrm>
           <a:prstGeom prst="roundRect">
             <a:avLst>
@@ -7784,7 +7784,7 @@
         <p:spPr>
           <a:xfrm>
             <a:off x="6351879" y="3277870"/>
-            <a:ext cx="2316403" cy="531876"/>
+            <a:ext cx="2316403" cy="862076"/>
           </a:xfrm>
           <a:prstGeom prst="rect">
             <a:avLst/>
@@ -7805,7 +7805,7 @@
                 </a:solidFill>
                 <a:latin typeface="Calibri"/>
               </a:rPr>
-              <a:t>Compare each week with the same distance from the event, never the same calendar week.</a:t>
+              <a:t>Diwali fell on 31 October 2024 and 20 October 2025, so the week before Diwali is compared with the week before Diwali, never the same calendar week.</a:t>
             </a:r>
           </a:p>
         </p:txBody>
@@ -7898,7 +7898,7 @@
         <p:spPr>
           <a:xfrm>
             <a:off x="9015755" y="2843784"/>
-            <a:ext cx="2645587" cy="1249680"/>
+            <a:ext cx="2645587" cy="1595120"/>
           </a:xfrm>
           <a:prstGeom prst="roundRect">
             <a:avLst>
@@ -9891,7 +9891,7 @@
         <p:spPr>
           <a:xfrm>
             <a:off x="530352" y="1956816"/>
-            <a:ext cx="2645587" cy="2385568"/>
+            <a:ext cx="2645587" cy="2724404"/>
           </a:xfrm>
           <a:prstGeom prst="roundRect">
             <a:avLst>
@@ -10083,7 +10083,7 @@
         <p:spPr>
           <a:xfrm>
             <a:off x="731519" y="3303524"/>
-            <a:ext cx="2243251" cy="581406"/>
+            <a:ext cx="2243251" cy="763016"/>
           </a:xfrm>
           <a:prstGeom prst="rect">
             <a:avLst/>
@@ -10104,7 +10104,7 @@
                 </a:solidFill>
                 <a:latin typeface="Calibri"/>
               </a:rPr>
-              <a:t>The monsoon ended inside the window, so a change in habits is possible.</a:t>
+              <a:t>You think shoppers changed when the monsoon ended, and a new layout would win the clicks back.</a:t>
             </a:r>
           </a:p>
         </p:txBody>
@@ -10118,7 +10118,7 @@
         <p:spPr>
           <a:xfrm>
             <a:off x="3358819" y="1956816"/>
-            <a:ext cx="2645587" cy="2385568"/>
+            <a:ext cx="2645587" cy="2724404"/>
           </a:xfrm>
           <a:prstGeom prst="roundRect">
             <a:avLst>
@@ -10296,7 +10296,7 @@
                 </a:solidFill>
                 <a:latin typeface="Calibri"/>
               </a:rPr>
-              <a:t>The fall sits in milk's slots</a:t>
+              <a:t>No rate fell; the mix moved</a:t>
             </a:r>
           </a:p>
         </p:txBody>
@@ -10310,7 +10310,7 @@
         <p:spPr>
           <a:xfrm>
             <a:off x="3559987" y="3534664"/>
-            <a:ext cx="2243251" cy="581406"/>
+            <a:ext cx="2243251" cy="763016"/>
           </a:xfrm>
           <a:prstGeom prst="rect">
             <a:avLst/>
@@ -10331,7 +10331,7 @@
                 </a:solidFill>
                 <a:latin typeface="Calibri"/>
               </a:rPr>
-              <a:t>Milk slots clicked 1.2 percent; every other slot 6.4, up from 6.2 before the change.</a:t>
+              <a:t>Milk went from 2 to 50 percent of impressions, clicking 1.2 percent in both windows; the rest rose in every slot.</a:t>
             </a:r>
           </a:p>
         </p:txBody>
@@ -10345,7 +10345,7 @@
         <p:spPr>
           <a:xfrm>
             <a:off x="6187287" y="1956816"/>
-            <a:ext cx="2645587" cy="2385568"/>
+            <a:ext cx="2645587" cy="2724404"/>
           </a:xfrm>
           <a:prstGeom prst="roundRect">
             <a:avLst>
@@ -10537,7 +10537,7 @@
         <p:spPr>
           <a:xfrm>
             <a:off x="6388455" y="3303524"/>
-            <a:ext cx="2243251" cy="581406"/>
+            <a:ext cx="2243251" cy="1126236"/>
           </a:xfrm>
           <a:prstGeom prst="rect">
             <a:avLst/>
@@ -10558,7 +10558,7 @@
                 </a:solidFill>
                 <a:latin typeface="Calibri"/>
               </a:rPr>
-              <a:t>Slot 1 draws 8.2 percent against 5.4 for slot 3, so a layout is worth testing on its own.</a:t>
+              <a:t>Among suggestions other than milk, slot 1 draws 8.2 percent against 5.4 for slot 3; a test that shuffles the order separates position from the strongest suggestion.</a:t>
             </a:r>
           </a:p>
         </p:txBody>
@@ -10572,7 +10572,7 @@
         <p:spPr>
           <a:xfrm>
             <a:off x="9015755" y="1956816"/>
-            <a:ext cx="2645587" cy="2385568"/>
+            <a:ext cx="2645587" cy="2724404"/>
           </a:xfrm>
           <a:prstGeom prst="roundRect">
             <a:avLst>
@@ -10735,7 +10735,7 @@
         <p:spPr>
           <a:xfrm>
             <a:off x="9216923" y="2962656"/>
-            <a:ext cx="2243251" cy="267716"/>
+            <a:ext cx="2243251" cy="498856"/>
           </a:xfrm>
           <a:prstGeom prst="rect">
             <a:avLst/>
@@ -10756,7 +10756,7 @@
                 </a:solidFill>
                 <a:latin typeface="Calibri"/>
               </a:rPr>
-              <a:t>If other slots fell too</a:t>
+              <a:t>If the rest had fallen too</a:t>
             </a:r>
           </a:p>
         </p:txBody>
@@ -10769,7 +10769,7 @@
         </p:nvSpPr>
         <p:spPr>
           <a:xfrm>
-            <a:off x="9216923" y="3303524"/>
+            <a:off x="9216923" y="3534664"/>
             <a:ext cx="2243251" cy="581406"/>
           </a:xfrm>
           <a:prstGeom prst="rect">
@@ -10791,7 +10791,7 @@
                 </a:solidFill>
                 <a:latin typeface="Calibri"/>
               </a:rPr>
-              <a:t>Had the non-milk slots fallen with milk's, the habits story would lead.</a:t>
+              <a:t>Had the suggestions other than milk fallen with the blend, the habits story would lead.</a:t>
             </a:r>
           </a:p>
         </p:txBody>
@@ -11404,8 +11404,8 @@
         </p:blipFill>
         <p:spPr>
           <a:xfrm>
-            <a:off x="1391568" y="1664208"/>
-            <a:ext cx="9408557" cy="3215640"/>
+            <a:off x="1795854" y="1664208"/>
+            <a:ext cx="8599986" cy="2939288"/>
           </a:xfrm>
           <a:prstGeom prst="rect">
             <a:avLst/>
@@ -11420,7 +11420,7 @@
         </p:nvSpPr>
         <p:spPr>
           <a:xfrm>
-            <a:off x="530352" y="4916424"/>
+            <a:off x="530352" y="4640072"/>
             <a:ext cx="11130991" cy="316992"/>
           </a:xfrm>
           <a:prstGeom prst="rect">
@@ -11455,8 +11455,8 @@
         </p:nvSpPr>
         <p:spPr>
           <a:xfrm>
-            <a:off x="530352" y="5242560"/>
-            <a:ext cx="11130991" cy="957072"/>
+            <a:off x="530352" y="4966208"/>
+            <a:ext cx="11130991" cy="1233424"/>
           </a:xfrm>
           <a:prstGeom prst="rect">
             <a:avLst/>
@@ -11476,7 +11476,7 @@
                 </a:solidFill>
                 <a:latin typeface="Calibri"/>
               </a:rPr>
-              <a:t>In every slot, suggestions other than milk clicked as well after the change as before; milk clicked low in all three. Shoppers who had changed their habits would have stopped clicking everything. A new layout is worth a test of its own; it is not what fell.</a:t>
+              <a:t>In every slot, suggestions other than milk clicked better after the change than before, 8.2 against 7.5 percent in slot 1; milk clicked 1.2 percent before and after, and only its share of impressions grew, from 2 to 50 percent. A new layout earns a test of its own, run beside the ranking as a two-by-two with customers randomised.</a:t>
             </a:r>
           </a:p>
         </p:txBody>
@@ -14096,7 +14096,7 @@
         <p:spPr>
           <a:xfrm>
             <a:off x="530352" y="1956816"/>
-            <a:ext cx="2645587" cy="2344420"/>
+            <a:ext cx="2645587" cy="2575560"/>
           </a:xfrm>
           <a:prstGeom prst="roundRect">
             <a:avLst>
@@ -14253,7 +14253,7 @@
         <p:spPr>
           <a:xfrm>
             <a:off x="731519" y="2962656"/>
-            <a:ext cx="2243251" cy="267716"/>
+            <a:ext cx="2243251" cy="498856"/>
           </a:xfrm>
           <a:prstGeom prst="rect">
             <a:avLst/>
@@ -14274,7 +14274,7 @@
                 </a:solidFill>
                 <a:latin typeface="Calibri"/>
               </a:rPr>
-              <a:t>Two zones alike</a:t>
+              <a:t>Two zones, shoppers split</a:t>
             </a:r>
           </a:p>
         </p:txBody>
@@ -14287,7 +14287,7 @@
         </p:nvSpPr>
         <p:spPr>
           <a:xfrm>
-            <a:off x="731519" y="3303524"/>
+            <a:off x="731519" y="3534664"/>
             <a:ext cx="2243251" cy="763016"/>
           </a:xfrm>
           <a:prstGeom prst="rect">
@@ -14309,7 +14309,7 @@
                 </a:solidFill>
                 <a:latin typeface="Calibri"/>
               </a:rPr>
-              <a:t>Two zones with similar carts and similar ice cream sales, one shown the pair and one left as it is.</a:t>
+              <a:t>In two zones, a random half of shoppers see the pair beside ice cream and the other half do not.</a:t>
             </a:r>
           </a:p>
         </p:txBody>
@@ -14323,7 +14323,7 @@
         <p:spPr>
           <a:xfrm>
             <a:off x="3358819" y="1956816"/>
-            <a:ext cx="2645587" cy="2344420"/>
+            <a:ext cx="2645587" cy="2575560"/>
           </a:xfrm>
           <a:prstGeom prst="roundRect">
             <a:avLst>
@@ -14550,7 +14550,7 @@
         <p:spPr>
           <a:xfrm>
             <a:off x="6187287" y="1956816"/>
-            <a:ext cx="2645587" cy="2344420"/>
+            <a:ext cx="2645587" cy="2575560"/>
           </a:xfrm>
           <a:prstGeom prst="roundRect">
             <a:avLst>
@@ -14707,7 +14707,7 @@
         <p:spPr>
           <a:xfrm>
             <a:off x="6388455" y="2962656"/>
-            <a:ext cx="2243251" cy="267716"/>
+            <a:ext cx="2243251" cy="498856"/>
           </a:xfrm>
           <a:prstGeom prst="rect">
             <a:avLst/>
@@ -14728,7 +14728,7 @@
                 </a:solidFill>
                 <a:latin typeface="Calibri"/>
               </a:rPr>
-              <a:t>The slot's own record</a:t>
+              <a:t>The shoppers who do not see it</a:t>
             </a:r>
           </a:p>
         </p:txBody>
@@ -14741,7 +14741,7 @@
         </p:nvSpPr>
         <p:spPr>
           <a:xfrm>
-            <a:off x="6388455" y="3303524"/>
+            <a:off x="6388455" y="3534664"/>
             <a:ext cx="2243251" cy="581406"/>
           </a:xfrm>
           <a:prstGeom prst="rect">
@@ -14763,7 +14763,7 @@
                 </a:solidFill>
                 <a:latin typeface="Calibri"/>
               </a:rPr>
-              <a:t>The pair must beat the click-through that slot drew in the same zones before the trial.</a:t>
+              <a:t>The pair's slot must beat the same slot for the other half, over the same weeks.</a:t>
             </a:r>
           </a:p>
         </p:txBody>
@@ -14777,7 +14777,7 @@
         <p:spPr>
           <a:xfrm>
             <a:off x="9015755" y="1956816"/>
-            <a:ext cx="2645587" cy="2344420"/>
+            <a:ext cx="2645587" cy="2575560"/>
           </a:xfrm>
           <a:prstGeom prst="roundRect">
             <a:avLst>
@@ -14961,7 +14961,7 @@
                 </a:solidFill>
                 <a:latin typeface="Calibri"/>
               </a:rPr>
-              <a:t>A shock in either zone</a:t>
+              <a:t>A shock to one half</a:t>
             </a:r>
           </a:p>
         </p:txBody>
@@ -14996,7 +14996,7 @@
                 </a:solidFill>
                 <a:latin typeface="Calibri"/>
               </a:rPr>
-              <a:t>A stock-out or a campaign in either zone voids the window and the trial restarts.</a:t>
+              <a:t>A stock-out or a campaign that reaches one half and not the other voids the window.</a:t>
             </a:r>
           </a:p>
         </p:txBody>
@@ -16245,7 +16245,7 @@
       </p:sp>
       <p:pic>
         <p:nvPicPr>
-          <p:cNvPr id="9" name="mermaid diagram" descr="0b06b4099da534f3.png"/>
+          <p:cNvPr id="9" name="mermaid diagram" descr="fd94701e24176345.png"/>
           <p:cNvPicPr>
             <a:picLocks noChangeAspect="1"/>
           </p:cNvPicPr>
@@ -16259,8 +16259,8 @@
         </p:blipFill>
         <p:spPr>
           <a:xfrm>
-            <a:off x="2152497" y="1787461"/>
-            <a:ext cx="7886700" cy="3286125"/>
+            <a:off x="2164370" y="1664208"/>
+            <a:ext cx="7862955" cy="3532632"/>
           </a:xfrm>
           <a:prstGeom prst="rect">
             <a:avLst/>
@@ -16296,7 +16296,7 @@
                 </a:solidFill>
                 <a:latin typeface="Calibri"/>
               </a:rPr>
-              <a:t>The pair is promoted when its slot beats the slot's own record by a margin set before the trial and its adds repay the slot in margin, after any bundle discount. If either fails, it stays on the watch list, which is what a watch list is for.</a:t>
+              <a:t>The pair is promoted when its slot beats the same slot for the shoppers not shown it, by a gap set before the trial, and its adds earn the slot's margin back, after any bundle discount. If either fails, it stays on the watch list, which is what a watch list is for.</a:t>
             </a:r>
           </a:p>
         </p:txBody>

</xml_diff>

<commit_message>
Week 4 Wednesday: the watch list passes on margin, and the mix moved
The thin pair's reach is about 2,400 of the strip's 60,000 views a day and its pass
rule compares the two halves' margin per shopper, in S30, S32's notes, S42, notebook 03,
the notes, the day sheet and fallback S2 to S4, whose data request is now each
shopper's half. Fallback S11 and S12 say the mix moved and milk's old cell slipped from
1.2 to 0.9 percent. Decks rebuilt and notebook 03 re-executed.

Co-Authored-By: Claude Opus 5.5 <noreply@anthropic.com>
Claude-Session: https://claude.ai/code/session_01NN5zp6kMYG3SQZMpC3fcxc
</commit_message>
<xml_diff>
--- a/content/W04/D3/slides/C2_W04_D03_fallback_STUDENT.pptx
+++ b/content/W04/D3/slides/C2_W04_D03_fallback_STUDENT.pptx
@@ -1053,7 +1053,7 @@
           <a:lstStyle/>
           <a:p>
             <a:r>
-              <a:t>LIVE, 7 minutes. The sentence to carry: "no rate fell; the mix moved, and a layout gets its own test".</a:t>
+              <a:t>LIVE, 7 minutes. The sentence to carry: "the mix moved, and a layout gets its own test".</a:t>
             </a:r>
           </a:p>
           <a:p>
@@ -1363,7 +1363,7 @@
           </a:p>
           <a:p>
             <a:r>
-              <a:t>the room to write the request in one sentence: which table, which new column, which dates.</a:t>
+              <a:t>the room to write the request in one sentence: which table, which new column, from which day.</a:t>
             </a:r>
           </a:p>
           <a:p>
@@ -1438,12 +1438,17 @@
           <a:lstStyle/>
           <a:p>
             <a:r>
-              <a:t>LIVE, 15 minutes. Groups present their pass rule in two sentences. The weak rule names only the</a:t>
-            </a:r>
-          </a:p>
-          <a:p>
-            <a:r>
-              <a:t>click-through; the strong rule names the rupees too. Transition: one zone, one time band.</a:t>
+              <a:t>LIVE, 15 minutes. Groups present their pass rule in two sentences. The weak rule names the slot's</a:t>
+            </a:r>
+          </a:p>
+          <a:p>
+            <a:r>
+              <a:t>click-through; the strong rule compares the two halves' margin per shopper on ice-cream carts, which</a:t>
+            </a:r>
+          </a:p>
+          <a:p>
+            <a:r>
+              <a:t>carries the discount and the adds that would have come anyway. Transition: one zone, one time band.</a:t>
             </a:r>
           </a:p>
         </p:txBody>
@@ -10275,7 +10280,7 @@
         <p:spPr>
           <a:xfrm>
             <a:off x="3559987" y="2962656"/>
-            <a:ext cx="2243251" cy="498856"/>
+            <a:ext cx="2243251" cy="267716"/>
           </a:xfrm>
           <a:prstGeom prst="rect">
             <a:avLst/>
@@ -10296,7 +10301,7 @@
                 </a:solidFill>
                 <a:latin typeface="Calibri"/>
               </a:rPr>
-              <a:t>No rate fell; the mix moved</a:t>
+              <a:t>The mix moved</a:t>
             </a:r>
           </a:p>
         </p:txBody>
@@ -10309,7 +10314,7 @@
         </p:nvSpPr>
         <p:spPr>
           <a:xfrm>
-            <a:off x="3559987" y="3534664"/>
+            <a:off x="3559987" y="3303524"/>
             <a:ext cx="2243251" cy="763016"/>
           </a:xfrm>
           <a:prstGeom prst="rect">
@@ -10331,7 +10336,7 @@
                 </a:solidFill>
                 <a:latin typeface="Calibri"/>
               </a:rPr>
-              <a:t>Milk went from 2 to 50 percent of impressions, clicking 1.2 percent in both windows; the rest rose in every slot.</a:t>
+              <a:t>Milk went from 2 to 50 percent of impressions at 0.9 to 1.4 percent, and the rest rose in every slot.</a:t>
             </a:r>
           </a:p>
         </p:txBody>
@@ -11476,7 +11481,7 @@
                 </a:solidFill>
                 <a:latin typeface="Calibri"/>
               </a:rPr>
-              <a:t>In every slot, suggestions other than milk clicked better after the change than before, 8.2 against 7.5 percent in slot 1; milk clicked 1.2 percent before and after, and only its share of impressions grew, from 2 to 50 percent. A new layout earns a test of its own, run beside the ranking as a two-by-two with customers randomised.</a:t>
+              <a:t>In every slot, suggestions other than milk clicked better after the change than before, 8.2 against 7.5 percent in slot 1. Milk's share of impressions grew from 2 to 50 percent at 0.9 to 1.4 percent; its old cell, slot 3, slipped from 1.2 to 0.9, too little to move the blend. A new layout earns a test of its own, run beside the ranking as a two-by-two with customers randomised.</a:t>
             </a:r>
           </a:p>
         </p:txBody>
@@ -14763,7 +14768,7 @@
                 </a:solidFill>
                 <a:latin typeface="Calibri"/>
               </a:rPr>
-              <a:t>The pair's slot must beat the same slot for the other half, over the same weeks.</a:t>
+              <a:t>The other half see the next-best suggestion in that slot, over the same weeks.</a:t>
             </a:r>
           </a:p>
         </p:txBody>
@@ -15553,7 +15558,7 @@
                 </a:solidFill>
                 <a:latin typeface="Georgia"/>
               </a:rPr>
-              <a:t>The trial's first need is a log split by zone</a:t>
+              <a:t>The trial's first need is each shopper's half</a:t>
             </a:r>
           </a:p>
         </p:txBody>
@@ -15588,14 +15593,14 @@
                 </a:solidFill>
                 <a:latin typeface="Calibri"/>
               </a:rPr>
-              <a:t>Can today's strip_log measure a two-zone trial?</a:t>
+              <a:t>Can today's tables measure a two-zone trial?</a:t>
             </a:r>
           </a:p>
         </p:txBody>
       </p:sp>
       <p:pic>
         <p:nvPicPr>
-          <p:cNvPr id="9" name="mermaid diagram" descr="6f2fefc937eff18b.png"/>
+          <p:cNvPr id="9" name="mermaid diagram" descr="980b14267228e04b.png"/>
           <p:cNvPicPr>
             <a:picLocks noChangeAspect="1"/>
           </p:cNvPicPr>
@@ -15609,8 +15614,8 @@
         </p:blipFill>
         <p:spPr>
           <a:xfrm>
-            <a:off x="2152497" y="1797050"/>
-            <a:ext cx="7886700" cy="3543300"/>
+            <a:off x="3194042" y="1664208"/>
+            <a:ext cx="5803609" cy="3532632"/>
           </a:xfrm>
           <a:prstGeom prst="rect">
             <a:avLst/>
@@ -15625,8 +15630,8 @@
         </p:nvSpPr>
         <p:spPr>
           <a:xfrm>
-            <a:off x="530352" y="5518912"/>
-            <a:ext cx="11130991" cy="680720"/>
+            <a:off x="530352" y="5242560"/>
+            <a:ext cx="11130991" cy="957072"/>
           </a:xfrm>
           <a:prstGeom prst="rect">
             <a:avLst/>
@@ -15646,7 +15651,7 @@
                 </a:solidFill>
                 <a:latin typeface="Calibri"/>
               </a:rPr>
-              <a:t>strip_log counts impressions, clicks and adds for the whole city; it has no zone column. A two-zone trial starts with a data request: the same log, split by zone, for the weeks before and during the trial.</a:t>
+              <a:t>strip_log counts impressions, clicks and adds for the whole city, with no zone and no shopper, so it cannot read a margin rule. carts holds the zone and the customer, and cart_items the margin on every line. A two-zone trial starts with a data request: which half each shopper was in, logged from the first day.</a:t>
             </a:r>
           </a:p>
         </p:txBody>
@@ -16203,7 +16208,7 @@
                 </a:solidFill>
                 <a:latin typeface="Georgia"/>
               </a:rPr>
-              <a:t>Pass only if the clicks and the rupees both hold</a:t>
+              <a:t>Pass only if the shown half earns more margin</a:t>
             </a:r>
           </a:p>
         </p:txBody>
@@ -16245,7 +16250,7 @@
       </p:sp>
       <p:pic>
         <p:nvPicPr>
-          <p:cNvPr id="9" name="mermaid diagram" descr="fd94701e24176345.png"/>
+          <p:cNvPr id="9" name="mermaid diagram" descr="5d603b4acd8bee51.png"/>
           <p:cNvPicPr>
             <a:picLocks noChangeAspect="1"/>
           </p:cNvPicPr>
@@ -16259,8 +16264,8 @@
         </p:blipFill>
         <p:spPr>
           <a:xfrm>
-            <a:off x="2164370" y="1664208"/>
-            <a:ext cx="7862955" cy="3532632"/>
+            <a:off x="3110022" y="1664208"/>
+            <a:ext cx="5971649" cy="3256279"/>
           </a:xfrm>
           <a:prstGeom prst="rect">
             <a:avLst/>
@@ -16275,8 +16280,8 @@
         </p:nvSpPr>
         <p:spPr>
           <a:xfrm>
-            <a:off x="530352" y="5242560"/>
-            <a:ext cx="11130991" cy="957072"/>
+            <a:off x="530352" y="4966208"/>
+            <a:ext cx="11130991" cy="1233424"/>
           </a:xfrm>
           <a:prstGeom prst="rect">
             <a:avLst/>
@@ -16296,7 +16301,7 @@
                 </a:solidFill>
                 <a:latin typeface="Calibri"/>
               </a:rPr>
-              <a:t>The pair is promoted when its slot beats the same slot for the shoppers not shown it, by a gap set before the trial, and its adds earn the slot's margin back, after any bundle discount. If either fails, it stays on the watch list, which is what a watch list is for.</a:t>
+              <a:t>The pair is promoted only if shoppers in the shown half earn more margin on their ice-cream carts than shoppers in the other half, after any bundle discount, by a gap set before the trial. Margin per shopper counts the sauce the strip sold and nets out the sauce they would have bought anyway, which a slot's click-through cannot. If it falls short, the pair stays on the watch list, which is what a watch list is for.</a:t>
             </a:r>
           </a:p>
         </p:txBody>

</xml_diff>

<commit_message>
Week 4 Wednesday: the decks, notebook and notes follow the confirmation read
S30, S32's notes, S42, S43, fallback S2 to S4, notebook 03, the notes and the day sheet
carry the thin pair at its own margins, the purchase-rate trial and the re-ranked strip
as the assistant's bar; the cold-reads file records the confirmation read verbatim and
what each finding became.

Co-Authored-By: Claude Opus 5.5 <noreply@anthropic.com>
Claude-Session: https://claude.ai/code/session_01NN5zp6kMYG3SQZMpC3fcxc
</commit_message>
<xml_diff>
--- a/content/W04/D3/slides/C2_W04_D03_fallback_STUDENT.pptx
+++ b/content/W04/D3/slides/C2_W04_D03_fallback_STUDENT.pptx
@@ -1443,12 +1443,17 @@
           </a:p>
           <a:p>
             <a:r>
-              <a:t>click-through; the strong rule compares the two halves' margin per shopper on ice-cream carts, which</a:t>
-            </a:r>
-          </a:p>
-          <a:p>
-            <a:r>
-              <a:t>carries the discount and the adds that would have come anyway. Transition: one zone, one time band.</a:t>
+              <a:t>click-through, which counts only shoppers who saw the pair; the strong rule compares sauce bought in</a:t>
+            </a:r>
+          </a:p>
+          <a:p>
+            <a:r>
+              <a:t>the two halves' ice-cream carts and keeps margin per shopper as the guardrail. Transition: one zone,</a:t>
+            </a:r>
+          </a:p>
+          <a:p>
+            <a:r>
+              <a:t>one time band.</a:t>
             </a:r>
           </a:p>
         </p:txBody>
@@ -15600,7 +15605,7 @@
       </p:sp>
       <p:pic>
         <p:nvPicPr>
-          <p:cNvPr id="9" name="mermaid diagram" descr="980b14267228e04b.png"/>
+          <p:cNvPr id="9" name="mermaid diagram" descr="72d7103e0d1ad14d.png"/>
           <p:cNvPicPr>
             <a:picLocks noChangeAspect="1"/>
           </p:cNvPicPr>
@@ -15651,7 +15656,7 @@
                 </a:solidFill>
                 <a:latin typeface="Calibri"/>
               </a:rPr>
-              <a:t>strip_log counts impressions, clicks and adds for the whole city, with no zone and no shopper, so it cannot read a margin rule. carts holds the zone and the customer, and cart_items the margin on every line. A two-zone trial starts with a data request: which half each shopper was in, logged from the first day.</a:t>
+              <a:t>strip_log counts impressions, clicks and adds for the whole city, with no zone and no shopper, so it cannot read the trial. carts holds the zone and the customer, and cart_items every item and its margin. A two-zone trial starts with a data request: which half each shopper was in, logged from the first day.</a:t>
             </a:r>
           </a:p>
         </p:txBody>
@@ -16208,7 +16213,7 @@
                 </a:solidFill>
                 <a:latin typeface="Georgia"/>
               </a:rPr>
-              <a:t>Pass only if the shown half earns more margin</a:t>
+              <a:t>Pass only if sauce sells more and margin holds</a:t>
             </a:r>
           </a:p>
         </p:txBody>
@@ -16250,7 +16255,7 @@
       </p:sp>
       <p:pic>
         <p:nvPicPr>
-          <p:cNvPr id="9" name="mermaid diagram" descr="5d603b4acd8bee51.png"/>
+          <p:cNvPr id="9" name="mermaid diagram" descr="5f44cab6e200e3db.png"/>
           <p:cNvPicPr>
             <a:picLocks noChangeAspect="1"/>
           </p:cNvPicPr>
@@ -16264,8 +16269,8 @@
         </p:blipFill>
         <p:spPr>
           <a:xfrm>
-            <a:off x="3110022" y="1664208"/>
-            <a:ext cx="5971649" cy="3256279"/>
+            <a:off x="530352" y="2332615"/>
+            <a:ext cx="4786326" cy="3216896"/>
           </a:xfrm>
           <a:prstGeom prst="rect">
             <a:avLst/>
@@ -16280,20 +16285,25 @@
         </p:nvSpPr>
         <p:spPr>
           <a:xfrm>
-            <a:off x="530352" y="4966208"/>
-            <a:ext cx="11130991" cy="1233424"/>
-          </a:xfrm>
-          <a:prstGeom prst="rect">
-            <a:avLst/>
-          </a:prstGeom>
-          <a:noFill/>
-        </p:spPr>
-        <p:txBody>
-          <a:bodyPr wrap="square" anchor="t" lIns="0" rIns="0" tIns="0" bIns="0">
-            <a:spAutoFit/>
-          </a:bodyPr>
-          <a:lstStyle/>
-          <a:p>
+            <a:off x="5761917" y="1956816"/>
+            <a:ext cx="5899425" cy="3259328"/>
+          </a:xfrm>
+          <a:prstGeom prst="rect">
+            <a:avLst/>
+          </a:prstGeom>
+          <a:noFill/>
+        </p:spPr>
+        <p:txBody>
+          <a:bodyPr wrap="square" anchor="t" lIns="0" rIns="0" tIns="0" bIns="0">
+            <a:spAutoFit/>
+          </a:bodyPr>
+          <a:lstStyle/>
+          <a:p>
+            <a:pPr>
+              <a:spcAft>
+                <a:spcPts val="800"/>
+              </a:spcAft>
+            </a:pPr>
             <a:r>
               <a:rPr sz="1600" b="0" i="0">
                 <a:solidFill>
@@ -16301,7 +16311,7 @@
                 </a:solidFill>
                 <a:latin typeface="Calibri"/>
               </a:rPr>
-              <a:t>The pair is promoted only if shoppers in the shown half earn more margin on their ice-cream carts than shoppers in the other half, after any bundle discount, by a gap set before the trial. Margin per shopper counts the sauce the strip sold and nets out the sauce they would have bought anyway, which a slot's click-through cannot. If it falls short, the pair stays on the watch list, which is what a watch list is for.</a:t>
+              <a:t>The pair is promoted only if ice-cream carts in the shown half buy sauce more often than the other half's, by a gap set before the trial, and margin per shopper, after any bundle discount, does not fall. Comparing the halves nets out the sauce shoppers would have bought anyway, which a slot's click-through cannot. The purchase rate is the read because it moves visibly when the strip works; a whole cart's margin swings too much to show a gain this size, so it guards the decision instead. If either fails, the pair stays on the watch list, which is what a watch list is for.</a:t>
             </a:r>
           </a:p>
         </p:txBody>

</xml_diff>